<commit_message>
Removed superfluous participant from the Director sequence diagram.
</commit_message>
<xml_diff>
--- a/LLM-D_Inference_Scheduler.pptx
+++ b/LLM-D_Inference_Scheduler.pptx
@@ -262,7 +262,7 @@
           <a:p>
             <a:fld id="{68DAC621-4D5B-4CA7-BBEB-263D1649B5B3}" type="datetimeFigureOut">
               <a:rPr lang="en-US" smtClean="0"/>
-              <a:t>3/7/2026</a:t>
+              <a:t>3/8/2026</a:t>
             </a:fld>
             <a:endParaRPr lang="en-US"/>
           </a:p>
@@ -460,7 +460,7 @@
           <a:p>
             <a:fld id="{68DAC621-4D5B-4CA7-BBEB-263D1649B5B3}" type="datetimeFigureOut">
               <a:rPr lang="en-US" smtClean="0"/>
-              <a:t>3/7/2026</a:t>
+              <a:t>3/8/2026</a:t>
             </a:fld>
             <a:endParaRPr lang="en-US"/>
           </a:p>
@@ -668,7 +668,7 @@
           <a:p>
             <a:fld id="{68DAC621-4D5B-4CA7-BBEB-263D1649B5B3}" type="datetimeFigureOut">
               <a:rPr lang="en-US" smtClean="0"/>
-              <a:t>3/7/2026</a:t>
+              <a:t>3/8/2026</a:t>
             </a:fld>
             <a:endParaRPr lang="en-US"/>
           </a:p>
@@ -866,7 +866,7 @@
           <a:p>
             <a:fld id="{68DAC621-4D5B-4CA7-BBEB-263D1649B5B3}" type="datetimeFigureOut">
               <a:rPr lang="en-US" smtClean="0"/>
-              <a:t>3/7/2026</a:t>
+              <a:t>3/8/2026</a:t>
             </a:fld>
             <a:endParaRPr lang="en-US"/>
           </a:p>
@@ -1141,7 +1141,7 @@
           <a:p>
             <a:fld id="{68DAC621-4D5B-4CA7-BBEB-263D1649B5B3}" type="datetimeFigureOut">
               <a:rPr lang="en-US" smtClean="0"/>
-              <a:t>3/7/2026</a:t>
+              <a:t>3/8/2026</a:t>
             </a:fld>
             <a:endParaRPr lang="en-US"/>
           </a:p>
@@ -1406,7 +1406,7 @@
           <a:p>
             <a:fld id="{68DAC621-4D5B-4CA7-BBEB-263D1649B5B3}" type="datetimeFigureOut">
               <a:rPr lang="en-US" smtClean="0"/>
-              <a:t>3/7/2026</a:t>
+              <a:t>3/8/2026</a:t>
             </a:fld>
             <a:endParaRPr lang="en-US"/>
           </a:p>
@@ -1818,7 +1818,7 @@
           <a:p>
             <a:fld id="{68DAC621-4D5B-4CA7-BBEB-263D1649B5B3}" type="datetimeFigureOut">
               <a:rPr lang="en-US" smtClean="0"/>
-              <a:t>3/7/2026</a:t>
+              <a:t>3/8/2026</a:t>
             </a:fld>
             <a:endParaRPr lang="en-US"/>
           </a:p>
@@ -1959,7 +1959,7 @@
           <a:p>
             <a:fld id="{68DAC621-4D5B-4CA7-BBEB-263D1649B5B3}" type="datetimeFigureOut">
               <a:rPr lang="en-US" smtClean="0"/>
-              <a:t>3/7/2026</a:t>
+              <a:t>3/8/2026</a:t>
             </a:fld>
             <a:endParaRPr lang="en-US"/>
           </a:p>
@@ -2072,7 +2072,7 @@
           <a:p>
             <a:fld id="{68DAC621-4D5B-4CA7-BBEB-263D1649B5B3}" type="datetimeFigureOut">
               <a:rPr lang="en-US" smtClean="0"/>
-              <a:t>3/7/2026</a:t>
+              <a:t>3/8/2026</a:t>
             </a:fld>
             <a:endParaRPr lang="en-US"/>
           </a:p>
@@ -2383,7 +2383,7 @@
           <a:p>
             <a:fld id="{68DAC621-4D5B-4CA7-BBEB-263D1649B5B3}" type="datetimeFigureOut">
               <a:rPr lang="en-US" smtClean="0"/>
-              <a:t>3/7/2026</a:t>
+              <a:t>3/8/2026</a:t>
             </a:fld>
             <a:endParaRPr lang="en-US"/>
           </a:p>
@@ -2671,7 +2671,7 @@
           <a:p>
             <a:fld id="{68DAC621-4D5B-4CA7-BBEB-263D1649B5B3}" type="datetimeFigureOut">
               <a:rPr lang="en-US" smtClean="0"/>
-              <a:t>3/7/2026</a:t>
+              <a:t>3/8/2026</a:t>
             </a:fld>
             <a:endParaRPr lang="en-US"/>
           </a:p>
@@ -2912,7 +2912,7 @@
           <a:p>
             <a:fld id="{68DAC621-4D5B-4CA7-BBEB-263D1649B5B3}" type="datetimeFigureOut">
               <a:rPr lang="en-US" smtClean="0"/>
-              <a:t>3/7/2026</a:t>
+              <a:t>3/8/2026</a:t>
             </a:fld>
             <a:endParaRPr lang="en-US"/>
           </a:p>
@@ -3397,10 +3397,10 @@
       </p:grpSpPr>
       <p:pic>
         <p:nvPicPr>
-          <p:cNvPr id="8" name="Graphic 7">
-            <a:extLst>
-              <a:ext uri="{FF2B5EF4-FFF2-40B4-BE49-F238E27FC236}">
-                <a16:creationId xmlns:a16="http://schemas.microsoft.com/office/drawing/2014/main" id="{597038BC-6DF4-7169-D297-427E63FA1858}"/>
+          <p:cNvPr id="3" name="Picture 2">
+            <a:extLst>
+              <a:ext uri="{FF2B5EF4-FFF2-40B4-BE49-F238E27FC236}">
+                <a16:creationId xmlns:a16="http://schemas.microsoft.com/office/drawing/2014/main" id="{BE826A5A-20CA-79F6-CA1C-36925A4F1BF9}"/>
               </a:ext>
             </a:extLst>
           </p:cNvPr>
@@ -3412,8 +3412,8 @@
         <p:blipFill>
           <a:blip r:embed="rId2">
             <a:extLst>
-              <a:ext uri="{96DAC541-7B7A-43D3-8B79-37D633B846F1}">
-                <asvg:svgBlip xmlns:asvg="http://schemas.microsoft.com/office/drawing/2016/SVG/main" r:embed="rId3"/>
+              <a:ext uri="{28A0092B-C50C-407E-A947-70E740481C1C}">
+                <a14:useLocalDpi xmlns:a14="http://schemas.microsoft.com/office/drawing/2010/main" val="0"/>
               </a:ext>
             </a:extLst>
           </a:blip>
@@ -3423,8 +3423,8 @@
         </p:blipFill>
         <p:spPr>
           <a:xfrm>
-            <a:off x="2362914" y="0"/>
-            <a:ext cx="7466172" cy="6858000"/>
+            <a:off x="2611072" y="0"/>
+            <a:ext cx="6969856" cy="6858000"/>
           </a:xfrm>
           <a:prstGeom prst="rect">
             <a:avLst/>

</xml_diff>

<commit_message>
Removed superfluous notation from Director sequence diagram.
</commit_message>
<xml_diff>
--- a/LLM-D_Inference_Scheduler.pptx
+++ b/LLM-D_Inference_Scheduler.pptx
@@ -3397,10 +3397,10 @@
       </p:grpSpPr>
       <p:pic>
         <p:nvPicPr>
-          <p:cNvPr id="3" name="Picture 2">
-            <a:extLst>
-              <a:ext uri="{FF2B5EF4-FFF2-40B4-BE49-F238E27FC236}">
-                <a16:creationId xmlns:a16="http://schemas.microsoft.com/office/drawing/2014/main" id="{BE826A5A-20CA-79F6-CA1C-36925A4F1BF9}"/>
+          <p:cNvPr id="4" name="Picture 3">
+            <a:extLst>
+              <a:ext uri="{FF2B5EF4-FFF2-40B4-BE49-F238E27FC236}">
+                <a16:creationId xmlns:a16="http://schemas.microsoft.com/office/drawing/2014/main" id="{0EA0A511-DA2B-9B2D-3DF7-24F716CBCF85}"/>
               </a:ext>
             </a:extLst>
           </p:cNvPr>
@@ -3423,8 +3423,8 @@
         </p:blipFill>
         <p:spPr>
           <a:xfrm>
-            <a:off x="2611072" y="0"/>
-            <a:ext cx="6969856" cy="6858000"/>
+            <a:off x="2552313" y="0"/>
+            <a:ext cx="7087373" cy="6858000"/>
           </a:xfrm>
           <a:prstGeom prst="rect">
             <a:avLst/>

</xml_diff>

<commit_message>
Added section describing sequences involving the Datastore.
</commit_message>
<xml_diff>
--- a/LLM-D_Inference_Scheduler.pptx
+++ b/LLM-D_Inference_Scheduler.pptx
@@ -8,7 +8,8 @@
     <p:sldId id="257" r:id="rId2"/>
     <p:sldId id="258" r:id="rId3"/>
     <p:sldId id="259" r:id="rId4"/>
-    <p:sldId id="260" r:id="rId5"/>
+    <p:sldId id="261" r:id="rId5"/>
+    <p:sldId id="260" r:id="rId6"/>
   </p:sldIdLst>
   <p:sldSz cx="12192000" cy="6858000"/>
   <p:notesSz cx="6858000" cy="9144000"/>
@@ -3511,6 +3512,78 @@
 </file>
 
 <file path=ppt/slides/slide4.xml><?xml version="1.0" encoding="utf-8"?>
+<p:sld xmlns:a="http://schemas.openxmlformats.org/drawingml/2006/main" xmlns:r="http://schemas.openxmlformats.org/officeDocument/2006/relationships" xmlns:p="http://schemas.openxmlformats.org/presentationml/2006/main">
+  <p:cSld>
+    <p:spTree>
+      <p:nvGrpSpPr>
+        <p:cNvPr id="1" name="">
+          <a:extLst>
+            <a:ext uri="{FF2B5EF4-FFF2-40B4-BE49-F238E27FC236}">
+              <a16:creationId xmlns:a16="http://schemas.microsoft.com/office/drawing/2014/main" id="{6A88AEFB-6E16-B9E8-AC30-6AF57FD02654}"/>
+            </a:ext>
+          </a:extLst>
+        </p:cNvPr>
+        <p:cNvGrpSpPr/>
+        <p:nvPr/>
+      </p:nvGrpSpPr>
+      <p:grpSpPr>
+        <a:xfrm>
+          <a:off x="0" y="0"/>
+          <a:ext cx="0" cy="0"/>
+          <a:chOff x="0" y="0"/>
+          <a:chExt cx="0" cy="0"/>
+        </a:xfrm>
+      </p:grpSpPr>
+      <p:pic>
+        <p:nvPicPr>
+          <p:cNvPr id="3" name="Picture 2">
+            <a:extLst>
+              <a:ext uri="{FF2B5EF4-FFF2-40B4-BE49-F238E27FC236}">
+                <a16:creationId xmlns:a16="http://schemas.microsoft.com/office/drawing/2014/main" id="{2E6D5824-F835-9E3D-F60F-C261EB2AFD86}"/>
+              </a:ext>
+            </a:extLst>
+          </p:cNvPr>
+          <p:cNvPicPr>
+            <a:picLocks noChangeAspect="1"/>
+          </p:cNvPicPr>
+          <p:nvPr/>
+        </p:nvPicPr>
+        <p:blipFill>
+          <a:blip r:embed="rId2">
+            <a:extLst>
+              <a:ext uri="{28A0092B-C50C-407E-A947-70E740481C1C}">
+                <a14:useLocalDpi xmlns:a14="http://schemas.microsoft.com/office/drawing/2010/main" val="0"/>
+              </a:ext>
+            </a:extLst>
+          </a:blip>
+          <a:stretch>
+            <a:fillRect/>
+          </a:stretch>
+        </p:blipFill>
+        <p:spPr>
+          <a:xfrm>
+            <a:off x="719879" y="0"/>
+            <a:ext cx="10752241" cy="6858000"/>
+          </a:xfrm>
+          <a:prstGeom prst="rect">
+            <a:avLst/>
+          </a:prstGeom>
+        </p:spPr>
+      </p:pic>
+    </p:spTree>
+    <p:extLst>
+      <p:ext uri="{BB962C8B-B14F-4D97-AF65-F5344CB8AC3E}">
+        <p14:creationId xmlns:p14="http://schemas.microsoft.com/office/powerpoint/2010/main" val="762129400"/>
+      </p:ext>
+    </p:extLst>
+  </p:cSld>
+  <p:clrMapOvr>
+    <a:masterClrMapping/>
+  </p:clrMapOvr>
+</p:sld>
+</file>
+
+<file path=ppt/slides/slide5.xml><?xml version="1.0" encoding="utf-8"?>
 <p:sld xmlns:a="http://schemas.openxmlformats.org/drawingml/2006/main" xmlns:r="http://schemas.openxmlformats.org/officeDocument/2006/relationships" xmlns:p="http://schemas.openxmlformats.org/presentationml/2006/main">
   <p:cSld>
     <p:spTree>

</xml_diff>